<commit_message>
Never seed a filing dated in the future
Marking a report late meant dating it two days past the end of its week.
For the week the dashboard is currently reporting on, that end has not
arrived yet, so the newest row in Recent activity was stamped eight days
ahead of today - the first thing anyone looks at, and plainly impossible.

Every seeded submission is now clamped to the moment the seed runs. A
report only reads as late if its clamped timestamp is still past its own
deadline, which can only happen once that week has actually closed. The
current week therefore shows three filed on time and two not filed, and
five genuinely late filings remain in the weeks behind it.

Slide 13 of the deck follows the same numbers, and the two bullets under
"Two details worth mentioning" were saying the same thing as each other;
one now covers the three-way split and the other the absent-row count.

Co-Authored-By: Claude Opus 5 <noreply@anthropic.com>
</commit_message>
<xml_diff>
--- a/docs/presentation.pptx
+++ b/docs/presentation.pptx
@@ -874,7 +874,7 @@
             <a:r>
               <a:rPr lang="en-US" dirty="0"/>
               <a:t>The dashboard is a single API call. Nine queries run in parallel with Promise.all, so the response takes about as long as the slowest one rather than the sum.
-'Not yet started' was the interesting one to compute. It's the absence of a row - so I start from the list of team members and subtract the ones who filed, rather than querying reports.</a:t>
+Compliance splits three ways: on time, late, and not filed. Late compares the first submission against the end of that week, so nobody can be late in a week that is still running. Not filed was the interesting one to compute - it is the absence of a row, so I start from the list of team members and subtract the ones who filed, rather than querying reports.</a:t>
             </a:r>
             <a:endParaRPr lang="en-US" dirty="0"/>
           </a:p>
@@ -5768,7 +5768,7 @@
                 <a:ea typeface="Calibri" pitchFamily="34" charset="-122"/>
                 <a:cs typeface="Calibri" pitchFamily="34" charset="-120"/>
               </a:rPr>
-              <a:t>2 on time, 1 late</a:t>
+              <a:t>3 on time, 2 pending</a:t>
             </a:r>
             <a:endParaRPr lang="en-US" sz="1200" dirty="0"/>
           </a:p>
@@ -6259,7 +6259,7 @@
                 <a:ea typeface="Calibri" pitchFamily="34" charset="-122"/>
                 <a:cs typeface="Calibri" pitchFamily="34" charset="-120"/>
               </a:rPr>
-              <a:t>"Not yet started" is the absence of a row - computed from the member list, not from reports</a:t>
+              <a:t>Compliance splits three ways: filed on time, filed after the week closed, and not filed at all</a:t>
             </a:r>
             <a:endParaRPr lang="en-US" sz="1300" dirty="0"/>
           </a:p>
@@ -6280,7 +6280,7 @@
                 <a:ea typeface="Calibri" pitchFamily="34" charset="-122"/>
                 <a:cs typeface="Calibri" pitchFamily="34" charset="-120"/>
               </a:rPr>
-              <a:t>Not filed at all is the absence of a row, so it is computed from the member list, not from reports</a:t>
+              <a:t>That last one is the absence of a row, so it is computed from the member list, not from reports</a:t>
             </a:r>
             <a:endParaRPr lang="en-US" sz="1300" dirty="0"/>
           </a:p>

</xml_diff>

<commit_message>
Bring the deck up to date with what the app now does
One slide added and five corrected. The deck claimed the AI assistant was not
built, which stopped being true; it now has its own slide between Testing and
Challenges, covering how it answers, what never leaves the server, and why a
free model tier is not a zero-retention one.

The rest were drift: project deletion is conditional now rather than always
archiving, the suite is eighteen tests rather than fifteen, and the deployment
slide said I ran out of time when what actually happened is that the API is
containerised and every free tier wants a card.

Co-Authored-By: Claude Opus 5 <noreply@anthropic.com>
</commit_message>
<xml_diff>
--- a/docs/presentation.pptx
+++ b/docs/presentation.pptx
@@ -19,6 +19,7 @@
     <p:sldId id="267" r:id="rId13"/>
     <p:sldId id="268" r:id="rId14"/>
     <p:sldId id="269" r:id="rId15"/>
+    <p:sldId id="273" r:id="rId24"/>
     <p:sldId id="270" r:id="rId16"/>
     <p:sldId id="271" r:id="rId17"/>
     <p:sldId id="272" r:id="rId18"/>
@@ -6422,7 +6423,7 @@
                 <a:ea typeface="Cambria" pitchFamily="34" charset="-122"/>
                 <a:cs typeface="Cambria" pitchFamily="34" charset="-120"/>
               </a:rPr>
-              <a:t>Fifteen tests, all on access control</a:t>
+              <a:t>Eighteen tests, all on access control</a:t>
             </a:r>
             <a:endParaRPr lang="en-US" sz="3400" dirty="0"/>
           </a:p>
@@ -6928,7 +6929,7 @@
                 <a:ea typeface="Calibri" pitchFamily="34" charset="-122"/>
                 <a:cs typeface="Calibri" pitchFamily="34" charset="-120"/>
               </a:rPr>
-              <a:t>Every assertion is a read or a rejected write, so the suite never disturbs the demo data - no separate test database needed</a:t>
+              <a:t>Almost all of it is reads and rejected writes. The two tests that do write put back what they changed, so the demo data survives the suite.</a:t>
             </a:r>
             <a:endParaRPr lang="en-US" sz="1350" dirty="0"/>
           </a:p>
@@ -7448,7 +7449,7 @@
                 <a:ea typeface="Cambria" pitchFamily="34" charset="-122"/>
                 <a:cs typeface="Cambria" pitchFamily="34" charset="-120"/>
               </a:rPr>
-              <a:t>Deployment is unfinished</a:t>
+              <a:t>Deployment ran into a wall</a:t>
             </a:r>
             <a:endParaRPr lang="en-US" sz="1600" dirty="0"/>
           </a:p>
@@ -7491,7 +7492,7 @@
                 <a:ea typeface="Calibri" pitchFamily="34" charset="-122"/>
                 <a:cs typeface="Calibri" pitchFamily="34" charset="-120"/>
               </a:rPr>
-              <a:t>Free-tier hosting for a Node API now generally wants card verification</a:t>
+              <a:t>Free-tier hosting for a long-lived Node API now wants card verification</a:t>
             </a:r>
             <a:endParaRPr lang="en-US" sz="1250" dirty="0"/>
           </a:p>
@@ -7512,7 +7513,7 @@
                 <a:ea typeface="Calibri" pitchFamily="34" charset="-122"/>
                 <a:cs typeface="Calibri" pitchFamily="34" charset="-120"/>
               </a:rPr>
-              <a:t>I ran out of time before a working deploy</a:t>
+              <a:t>The API is containerised; the frontend is live on Vercel</a:t>
             </a:r>
             <a:endParaRPr lang="en-US" sz="1250" dirty="0"/>
           </a:p>
@@ -8062,7 +8063,7 @@
                 <a:ea typeface="Cambria" pitchFamily="34" charset="-122"/>
                 <a:cs typeface="Cambria" pitchFamily="34" charset="-120"/>
               </a:rPr>
-              <a:t>AI assistant</a:t>
+              <a:t>Project membership</a:t>
             </a:r>
             <a:endParaRPr lang="en-US" sz="1550" dirty="0"/>
           </a:p>
@@ -8101,7 +8102,7 @@
                 <a:ea typeface="Calibri" pitchFamily="34" charset="-122"/>
                 <a:cs typeface="Calibri" pitchFamily="34" charset="-120"/>
               </a:rPr>
-              <a:t>Not built. A manager asks what the team worked on; the week's reports go to an LLM as context - scoped to what that manager may already see.</a:t>
+              <a:t>ProjectMember is in the schema and seeded, but nothing assigns people to projects yet - the dashboard could then filter by it.</a:t>
             </a:r>
             <a:endParaRPr lang="en-US" sz="1250" dirty="0"/>
           </a:p>
@@ -8690,7 +8691,7 @@
                 <a:ea typeface="Cambria" pitchFamily="34" charset="-122"/>
                 <a:cs typeface="Cambria" pitchFamily="34" charset="-120"/>
               </a:rPr>
-              <a:t>15</a:t>
+              <a:t>18</a:t>
             </a:r>
             <a:endParaRPr lang="en-US" sz="3600" dirty="0"/>
           </a:p>
@@ -8849,6 +8850,471 @@
               <a:t>github.com/RVViduranga/weekly-report-dashboard</a:t>
             </a:r>
             <a:endParaRPr lang="en-US" sz="1300" dirty="0"/>
+          </a:p>
+        </p:txBody>
+      </p:sp>
+    </p:spTree>
+  </p:cSld>
+  <p:clrMapOvr>
+    <a:masterClrMapping/>
+  </p:clrMapOvr>
+</p:sld>
+</file>
+
+<file path=ppt/slides/slide18.xml><?xml version="1.0" encoding="utf-8"?>
+<p:sld xmlns:a="http://schemas.openxmlformats.org/drawingml/2006/main" xmlns:r="http://schemas.openxmlformats.org/officeDocument/2006/relationships" xmlns:p="http://schemas.openxmlformats.org/presentationml/2006/main">
+  <p:cSld name="Slide 6">
+    <p:spTree>
+      <p:nvGrpSpPr>
+        <p:cNvPr id="1" name=""/>
+        <p:cNvGrpSpPr/>
+        <p:nvPr/>
+      </p:nvGrpSpPr>
+      <p:grpSpPr>
+        <a:xfrm>
+          <a:off x="0" y="0"/>
+          <a:ext cx="0" cy="0"/>
+          <a:chOff x="0" y="0"/>
+          <a:chExt cx="0" cy="0"/>
+        </a:xfrm>
+      </p:grpSpPr>
+      <p:sp>
+        <p:nvSpPr>
+          <p:cNvPr id="2" name="Text 0"/>
+          <p:cNvSpPr txBox="1"/>
+          <p:nvPr/>
+        </p:nvSpPr>
+        <p:spPr>
+          <a:xfrm>
+            <a:off x="640080" y="411480"/>
+            <a:ext cx="10881360" cy="274320"/>
+          </a:xfrm>
+          <a:prstGeom prst="rect">
+            <a:avLst/>
+          </a:prstGeom>
+          <a:noFill/>
+          <a:ln/>
+        </p:spPr>
+        <p:txBody>
+          <a:bodyPr wrap="square" lIns="0" tIns="0" rIns="0" bIns="0" rtlCol="0" anchor="ctr"/>
+          <a:lstStyle/>
+          <a:p>
+            <a:pPr indent="0" marL="0">
+              <a:buNone/>
+            </a:pPr>
+            <a:r>
+              <a:rPr lang="en-US" sz="1100" b="1" spc="200" kern="0" dirty="0">
+                <a:solidFill>
+                  <a:srgbClr val="C8873A"/>
+                </a:solidFill>
+                <a:latin typeface="Calibri" pitchFamily="34" charset="0"/>
+                <a:ea typeface="Calibri" pitchFamily="34" charset="-122"/>
+                <a:cs typeface="Calibri" pitchFamily="34" charset="-120"/>
+              </a:rPr>
+              <a:t>AI CHAT ASSISTANT</a:t>
+            </a:r>
+            <a:endParaRPr lang="en-US" sz="1100" dirty="0"/>
+          </a:p>
+        </p:txBody>
+      </p:sp>
+      <p:sp>
+        <p:nvSpPr>
+          <p:cNvPr id="3" name="Text 1"/>
+          <p:cNvSpPr txBox="1"/>
+          <p:nvPr/>
+        </p:nvSpPr>
+        <p:spPr>
+          <a:xfrm>
+            <a:off x="640080" y="685800"/>
+            <a:ext cx="10881360" cy="685800"/>
+          </a:xfrm>
+          <a:prstGeom prst="rect">
+            <a:avLst/>
+          </a:prstGeom>
+          <a:noFill/>
+          <a:ln/>
+        </p:spPr>
+        <p:txBody>
+          <a:bodyPr wrap="square" lIns="0" tIns="0" rIns="0" bIns="0" rtlCol="0" anchor="ctr"/>
+          <a:lstStyle/>
+          <a:p>
+            <a:pPr indent="0" marL="0">
+              <a:buNone/>
+            </a:pPr>
+            <a:r>
+              <a:rPr lang="en-US" sz="3400" b="1" dirty="0">
+                <a:solidFill>
+                  <a:srgbClr val="17211C"/>
+                </a:solidFill>
+                <a:latin typeface="Cambria" pitchFamily="34" charset="0"/>
+                <a:ea typeface="Cambria" pitchFamily="34" charset="-122"/>
+                <a:cs typeface="Cambria" pitchFamily="34" charset="-120"/>
+              </a:rPr>
+              <a:t>Grounded in the reports, not the model</a:t>
+            </a:r>
+            <a:endParaRPr lang="en-US" sz="3400" dirty="0"/>
+          </a:p>
+        </p:txBody>
+      </p:sp>
+      <p:sp>
+        <p:nvSpPr>
+          <p:cNvPr id="4" name="Shape 2"/>
+          <p:cNvSpPr/>
+          <p:nvPr/>
+        </p:nvSpPr>
+        <p:spPr>
+          <a:xfrm>
+            <a:off x="640080" y="1554480"/>
+            <a:ext cx="5303520" cy="3200400"/>
+          </a:xfrm>
+          <a:prstGeom prst="roundRect">
+            <a:avLst>
+              <a:gd name="adj" fmla="val 2571"/>
+            </a:avLst>
+          </a:prstGeom>
+          <a:solidFill>
+            <a:srgbClr val="EFF4F0"/>
+          </a:solidFill>
+          <a:ln w="12700">
+            <a:solidFill>
+              <a:srgbClr val="EFF4F0"/>
+            </a:solidFill>
+            <a:prstDash val="solid"/>
+          </a:ln>
+        </p:spPr>
+      </p:sp>
+      <p:sp>
+        <p:nvSpPr>
+          <p:cNvPr id="5" name="Text 3"/>
+          <p:cNvSpPr txBox="1"/>
+          <p:nvPr/>
+        </p:nvSpPr>
+        <p:spPr>
+          <a:xfrm>
+            <a:off x="896112" y="1755648"/>
+            <a:ext cx="4791456" cy="310896"/>
+          </a:xfrm>
+          <a:prstGeom prst="rect">
+            <a:avLst/>
+          </a:prstGeom>
+          <a:noFill/>
+          <a:ln/>
+        </p:spPr>
+        <p:txBody>
+          <a:bodyPr wrap="square" lIns="0" tIns="0" rIns="0" bIns="0" rtlCol="0" anchor="ctr"/>
+          <a:lstStyle/>
+          <a:p>
+            <a:pPr indent="0" marL="0">
+              <a:buNone/>
+            </a:pPr>
+            <a:r>
+              <a:rPr lang="en-US" sz="1700" b="1" dirty="0">
+                <a:solidFill>
+                  <a:srgbClr val="1F4D3A"/>
+                </a:solidFill>
+                <a:latin typeface="Cambria" pitchFamily="34" charset="0"/>
+                <a:ea typeface="Cambria" pitchFamily="34" charset="-122"/>
+                <a:cs typeface="Cambria" pitchFamily="34" charset="-120"/>
+              </a:rPr>
+              <a:t>How it answers</a:t>
+            </a:r>
+            <a:endParaRPr lang="en-US" sz="1700" dirty="0"/>
+          </a:p>
+        </p:txBody>
+      </p:sp>
+      <p:sp>
+        <p:nvSpPr>
+          <p:cNvPr id="6" name="Text 4"/>
+          <p:cNvSpPr txBox="1"/>
+          <p:nvPr/>
+        </p:nvSpPr>
+        <p:spPr>
+          <a:xfrm>
+            <a:off x="896112" y="2176272"/>
+            <a:ext cx="4791456" cy="2414016"/>
+          </a:xfrm>
+          <a:prstGeom prst="rect">
+            <a:avLst/>
+          </a:prstGeom>
+          <a:noFill/>
+          <a:ln/>
+        </p:spPr>
+        <p:txBody>
+          <a:bodyPr wrap="square" lIns="0" tIns="0" rIns="0" bIns="0" rtlCol="0" anchor="t"/>
+          <a:lstStyle/>
+          <a:p>
+            <a:pPr marL="342900" indent="-342900">
+              <a:spcAft>
+                <a:spcPts val="500"/>
+              </a:spcAft>
+              <a:buSzPct val="100000"/>
+              <a:buChar char="•"/>
+            </a:pPr>
+            <a:r>
+              <a:rPr lang="en-US" sz="1300" dirty="0">
+                <a:solidFill>
+                  <a:srgbClr val="17211C"/>
+                </a:solidFill>
+                <a:latin typeface="Calibri" pitchFamily="34" charset="0"/>
+                <a:ea typeface="Calibri" pitchFamily="34" charset="-122"/>
+                <a:cs typeface="Calibri" pitchFamily="34" charset="-120"/>
+              </a:rPr>
+              <a:t>Manager-only, behind the same requireRole guard</a:t>
+            </a:r>
+            <a:endParaRPr lang="en-US" sz="1300" dirty="0"/>
+          </a:p>
+          <a:p>
+            <a:pPr marL="342900" indent="-342900">
+              <a:spcAft>
+                <a:spcPts val="500"/>
+              </a:spcAft>
+              <a:buSzPct val="100000"/>
+              <a:buChar char="•"/>
+            </a:pPr>
+            <a:r>
+              <a:rPr lang="en-US" sz="1300" dirty="0">
+                <a:solidFill>
+                  <a:srgbClr val="17211C"/>
+                </a:solidFill>
+                <a:latin typeface="Calibri" pitchFamily="34" charset="0"/>
+                <a:ea typeface="Calibri" pitchFamily="34" charset="-122"/>
+                <a:cs typeface="Calibri" pitchFamily="34" charset="-120"/>
+              </a:rPr>
+              <a:t>The week's reports are rendered as plain text into a system message</a:t>
+            </a:r>
+            <a:endParaRPr lang="en-US" sz="1300" dirty="0"/>
+          </a:p>
+          <a:p>
+            <a:pPr marL="342900" indent="-342900">
+              <a:spcAft>
+                <a:spcPts val="500"/>
+              </a:spcAft>
+              <a:buSzPct val="100000"/>
+              <a:buChar char="•"/>
+            </a:pPr>
+            <a:r>
+              <a:rPr lang="en-US" sz="1300" dirty="0">
+                <a:solidFill>
+                  <a:srgbClr val="17211C"/>
+                </a:solidFill>
+                <a:latin typeface="Calibri" pitchFamily="34" charset="0"/>
+                <a:ea typeface="Calibri" pitchFamily="34" charset="-122"/>
+                <a:cs typeface="Calibri" pitchFamily="34" charset="-120"/>
+              </a:rPr>
+              <a:t>No vector store and no retrieval - a week is a few kilobytes</a:t>
+            </a:r>
+            <a:endParaRPr lang="en-US" sz="1300" dirty="0"/>
+          </a:p>
+          <a:p>
+            <a:pPr marL="342900" indent="-342900">
+              <a:spcAft>
+                <a:spcPts val="500"/>
+              </a:spcAft>
+              <a:buSzPct val="100000"/>
+              <a:buChar char="•"/>
+            </a:pPr>
+            <a:r>
+              <a:rPr lang="en-US" sz="1300" dirty="0">
+                <a:solidFill>
+                  <a:srgbClr val="17211C"/>
+                </a:solidFill>
+                <a:latin typeface="Calibri" pitchFamily="34" charset="0"/>
+                <a:ea typeface="Calibri" pitchFamily="34" charset="-122"/>
+                <a:cs typeface="Calibri" pitchFamily="34" charset="-120"/>
+              </a:rPr>
+              <a:t>Six free models tried in order, because a shared pool answers 429</a:t>
+            </a:r>
+            <a:endParaRPr lang="en-US" sz="1300" dirty="0"/>
+          </a:p>
+        </p:txBody>
+      </p:sp>
+      <p:sp>
+        <p:nvSpPr>
+          <p:cNvPr id="7" name="Shape 5"/>
+          <p:cNvSpPr/>
+          <p:nvPr/>
+        </p:nvSpPr>
+        <p:spPr>
+          <a:xfrm>
+            <a:off x="6217920" y="1554480"/>
+            <a:ext cx="5303520" cy="3200400"/>
+          </a:xfrm>
+          <a:prstGeom prst="roundRect">
+            <a:avLst>
+              <a:gd name="adj" fmla="val 2571"/>
+            </a:avLst>
+          </a:prstGeom>
+          <a:solidFill>
+            <a:srgbClr val="EFF4F0"/>
+          </a:solidFill>
+          <a:ln w="12700">
+            <a:solidFill>
+              <a:srgbClr val="EFF4F0"/>
+            </a:solidFill>
+            <a:prstDash val="solid"/>
+          </a:ln>
+        </p:spPr>
+      </p:sp>
+      <p:sp>
+        <p:nvSpPr>
+          <p:cNvPr id="8" name="Text 6"/>
+          <p:cNvSpPr txBox="1"/>
+          <p:nvPr/>
+        </p:nvSpPr>
+        <p:spPr>
+          <a:xfrm>
+            <a:off x="6473952" y="1755648"/>
+            <a:ext cx="4791456" cy="310896"/>
+          </a:xfrm>
+          <a:prstGeom prst="rect">
+            <a:avLst/>
+          </a:prstGeom>
+          <a:noFill/>
+          <a:ln/>
+        </p:spPr>
+        <p:txBody>
+          <a:bodyPr wrap="square" lIns="0" tIns="0" rIns="0" bIns="0" rtlCol="0" anchor="ctr"/>
+          <a:lstStyle/>
+          <a:p>
+            <a:pPr indent="0" marL="0">
+              <a:buNone/>
+            </a:pPr>
+            <a:r>
+              <a:rPr lang="en-US" sz="1700" b="1" dirty="0">
+                <a:solidFill>
+                  <a:srgbClr val="1F4D3A"/>
+                </a:solidFill>
+                <a:latin typeface="Cambria" pitchFamily="34" charset="0"/>
+                <a:ea typeface="Cambria" pitchFamily="34" charset="-122"/>
+                <a:cs typeface="Cambria" pitchFamily="34" charset="-120"/>
+              </a:rPr>
+              <a:t>What never leaves the server</a:t>
+            </a:r>
+            <a:endParaRPr lang="en-US" sz="1700" dirty="0"/>
+          </a:p>
+        </p:txBody>
+      </p:sp>
+      <p:sp>
+        <p:nvSpPr>
+          <p:cNvPr id="9" name="Text 7"/>
+          <p:cNvSpPr txBox="1"/>
+          <p:nvPr/>
+        </p:nvSpPr>
+        <p:spPr>
+          <a:xfrm>
+            <a:off x="6473952" y="2176272"/>
+            <a:ext cx="4791456" cy="2414016"/>
+          </a:xfrm>
+          <a:prstGeom prst="rect">
+            <a:avLst/>
+          </a:prstGeom>
+          <a:noFill/>
+          <a:ln/>
+        </p:spPr>
+        <p:txBody>
+          <a:bodyPr wrap="square" lIns="0" tIns="0" rIns="0" bIns="0" rtlCol="0" anchor="t"/>
+          <a:lstStyle/>
+          <a:p>
+            <a:pPr marL="342900" indent="-342900">
+              <a:spcAft>
+                <a:spcPts val="500"/>
+              </a:spcAft>
+              <a:buSzPct val="100000"/>
+              <a:buChar char="•"/>
+            </a:pPr>
+            <a:r>
+              <a:rPr lang="en-US" sz="1300" dirty="0">
+                <a:solidFill>
+                  <a:srgbClr val="17211C"/>
+                </a:solidFill>
+                <a:latin typeface="Calibri" pitchFamily="34" charset="0"/>
+                <a:ea typeface="Calibri" pitchFamily="34" charset="-122"/>
+                <a:cs typeface="Calibri" pitchFamily="34" charset="-120"/>
+              </a:rPr>
+              <a:t>The Prisma select is the boundary, not the prompt</a:t>
+            </a:r>
+            <a:endParaRPr lang="en-US" sz="1300" dirty="0"/>
+          </a:p>
+          <a:p>
+            <a:pPr marL="342900" indent="-342900">
+              <a:spcAft>
+                <a:spcPts val="500"/>
+              </a:spcAft>
+              <a:buSzPct val="100000"/>
+              <a:buChar char="•"/>
+            </a:pPr>
+            <a:r>
+              <a:rPr lang="en-US" sz="1300" dirty="0">
+                <a:solidFill>
+                  <a:srgbClr val="17211C"/>
+                </a:solidFill>
+                <a:latin typeface="Calibri" pitchFamily="34" charset="0"/>
+                <a:ea typeface="Calibri" pitchFamily="34" charset="-122"/>
+                <a:cs typeface="Calibri" pitchFamily="34" charset="-120"/>
+              </a:rPr>
+              <a:t>Names are selected; emails, ids and password hashes are not</a:t>
+            </a:r>
+            <a:endParaRPr lang="en-US" sz="1300" dirty="0"/>
+          </a:p>
+          <a:p>
+            <a:pPr marL="342900" indent="-342900">
+              <a:spcAft>
+                <a:spcPts val="500"/>
+              </a:spcAft>
+              <a:buSzPct val="100000"/>
+              <a:buChar char="•"/>
+            </a:pPr>
+            <a:r>
+              <a:rPr lang="en-US" sz="1300" dirty="0">
+                <a:solidFill>
+                  <a:srgbClr val="17211C"/>
+                </a:solidFill>
+                <a:latin typeface="Calibri" pitchFamily="34" charset="0"/>
+                <a:ea typeface="Calibri" pitchFamily="34" charset="-122"/>
+                <a:cs typeface="Calibri" pitchFamily="34" charset="-120"/>
+              </a:rPr>
+              <a:t>The browser cannot send a system message, only user and assistant</a:t>
+            </a:r>
+            <a:endParaRPr lang="en-US" sz="1300" dirty="0"/>
+          </a:p>
+        </p:txBody>
+      </p:sp>
+      <p:sp>
+        <p:nvSpPr>
+          <p:cNvPr id="10" name="Text 8"/>
+          <p:cNvSpPr txBox="1"/>
+          <p:nvPr/>
+        </p:nvSpPr>
+        <p:spPr>
+          <a:xfrm>
+            <a:off x="640080" y="5029200"/>
+            <a:ext cx="10881360" cy="731520"/>
+          </a:xfrm>
+          <a:prstGeom prst="rect">
+            <a:avLst/>
+          </a:prstGeom>
+          <a:noFill/>
+          <a:ln/>
+        </p:spPr>
+        <p:txBody>
+          <a:bodyPr wrap="square" lIns="0" tIns="0" rIns="0" bIns="0" rtlCol="0" anchor="ctr"/>
+          <a:lstStyle/>
+          <a:p>
+            <a:pPr indent="0" marL="0">
+              <a:buNone/>
+            </a:pPr>
+            <a:r>
+              <a:rPr lang="en-US" sz="1350" i="1" dirty="0">
+                <a:solidFill>
+                  <a:srgbClr val="17211C"/>
+                </a:solidFill>
+                <a:latin typeface="Calibri" pitchFamily="34" charset="0"/>
+                <a:ea typeface="Calibri" pitchFamily="34" charset="-122"/>
+                <a:cs typeface="Calibri" pitchFamily="34" charset="-120"/>
+              </a:rPr>
+              <a:t>A free model tier is not zero-retention: the provider may train on what is sent. Fine for seeded demo data, not for a real team - production would use a zero-retention tier or a self-hosted model.</a:t>
+            </a:r>
+            <a:endParaRPr lang="en-US" sz="1350" dirty="0"/>
           </a:p>
         </p:txBody>
       </p:sp>
@@ -11470,7 +11936,7 @@
                 <a:ea typeface="Cambria" pitchFamily="34" charset="-122"/>
                 <a:cs typeface="Cambria" pitchFamily="34" charset="-120"/>
               </a:rPr>
-              <a:t>Projects are archived, not deleted</a:t>
+              <a:t>A project is deleted only when that is safe</a:t>
             </a:r>
             <a:endParaRPr lang="en-US" sz="1700" dirty="0"/>
           </a:p>
@@ -11513,7 +11979,7 @@
                 <a:ea typeface="Calibri" pitchFamily="34" charset="-122"/>
                 <a:cs typeface="Calibri" pitchFamily="34" charset="-120"/>
               </a:rPr>
-              <a:t>Delete sets isActive = false</a:t>
+              <a:t>Nothing references it, so the row really is deleted</a:t>
             </a:r>
             <a:endParaRPr lang="en-US" sz="1300" dirty="0"/>
           </a:p>
@@ -11534,7 +12000,7 @@
                 <a:ea typeface="Calibri" pitchFamily="34" charset="-122"/>
                 <a:cs typeface="Calibri" pitchFamily="34" charset="-120"/>
               </a:rPr>
-              <a:t>Hidden from new reports, kept for old ones</a:t>
+              <a:t>Reports reference it, so isActive becomes false instead</a:t>
             </a:r>
             <a:endParaRPr lang="en-US" sz="1300" dirty="0"/>
           </a:p>
@@ -11555,7 +12021,7 @@
                 <a:ea typeface="Calibri" pitchFamily="34" charset="-122"/>
                 <a:cs typeface="Calibri" pitchFamily="34" charset="-120"/>
               </a:rPr>
-              <a:t>Hard-deleting would either fail on the foreign key or orphan months of history</a:t>
+              <a:t>Report.projectId is not nullable and carries no cascade, so Postgres refuses the other path</a:t>
             </a:r>
             <a:endParaRPr lang="en-US" sz="1300" dirty="0"/>
           </a:p>

</xml_diff>